<commit_message>
Finished intro slides, started working on data slides.
</commit_message>
<xml_diff>
--- a/Presentation/Komparativna analiza ML metodologija.pptx
+++ b/Presentation/Komparativna analiza ML metodologija.pptx
@@ -5,7 +5,7 @@
     <p:sldMasterId id="2147483648" r:id="rId1"/>
   </p:sldMasterIdLst>
   <p:notesMasterIdLst>
-    <p:notesMasterId r:id="rId8"/>
+    <p:notesMasterId r:id="rId9"/>
   </p:notesMasterIdLst>
   <p:sldIdLst>
     <p:sldId id="256" r:id="rId2"/>
@@ -13,7 +13,8 @@
     <p:sldId id="262" r:id="rId4"/>
     <p:sldId id="266" r:id="rId5"/>
     <p:sldId id="267" r:id="rId6"/>
-    <p:sldId id="268" r:id="rId7"/>
+    <p:sldId id="271" r:id="rId7"/>
+    <p:sldId id="268" r:id="rId8"/>
   </p:sldIdLst>
   <p:sldSz cx="12192000" cy="6858000"/>
   <p:notesSz cx="6858000" cy="9144000"/>
@@ -202,7 +203,7 @@
           <a:p>
             <a:fld id="{CA5A90D3-49B2-4DF6-BAF7-8B743C4BA0C6}" type="datetimeFigureOut">
               <a:rPr lang="en-US" smtClean="0"/>
-              <a:t>8/17/2026</a:t>
+              <a:t>8/18/2026</a:t>
             </a:fld>
             <a:endParaRPr lang="en-US"/>
           </a:p>
@@ -2007,6 +2008,1257 @@
 </p:notes>
 </file>
 
+<file path=ppt/notesSlides/notesSlide3.xml><?xml version="1.0" encoding="utf-8"?>
+<p:notes xmlns:a="http://schemas.openxmlformats.org/drawingml/2006/main" xmlns:r="http://schemas.openxmlformats.org/officeDocument/2006/relationships" xmlns:p="http://schemas.openxmlformats.org/presentationml/2006/main">
+  <p:cSld>
+    <p:spTree>
+      <p:nvGrpSpPr>
+        <p:cNvPr id="1" name=""/>
+        <p:cNvGrpSpPr/>
+        <p:nvPr/>
+      </p:nvGrpSpPr>
+      <p:grpSpPr>
+        <a:xfrm>
+          <a:off x="0" y="0"/>
+          <a:ext cx="0" cy="0"/>
+          <a:chOff x="0" y="0"/>
+          <a:chExt cx="0" cy="0"/>
+        </a:xfrm>
+      </p:grpSpPr>
+      <p:sp>
+        <p:nvSpPr>
+          <p:cNvPr id="2" name="Slide Image Placeholder 1"/>
+          <p:cNvSpPr>
+            <a:spLocks noGrp="1" noRot="1" noChangeAspect="1"/>
+          </p:cNvSpPr>
+          <p:nvPr>
+            <p:ph type="sldImg"/>
+          </p:nvPr>
+        </p:nvSpPr>
+        <p:spPr/>
+      </p:sp>
+      <p:sp>
+        <p:nvSpPr>
+          <p:cNvPr id="3" name="Notes Placeholder 2"/>
+          <p:cNvSpPr>
+            <a:spLocks noGrp="1"/>
+          </p:cNvSpPr>
+          <p:nvPr>
+            <p:ph type="body" idx="1"/>
+          </p:nvPr>
+        </p:nvSpPr>
+        <p:spPr/>
+        <p:txBody>
+          <a:bodyPr/>
+          <a:lstStyle/>
+          <a:p>
+            <a:r>
+              <a:rPr lang="en-US" b="0" dirty="0" err="1"/>
+              <a:t>Zašto</a:t>
+            </a:r>
+            <a:r>
+              <a:rPr lang="en-US" b="0" dirty="0"/>
+              <a:t> </a:t>
+            </a:r>
+            <a:r>
+              <a:rPr lang="en-US" b="0" dirty="0" err="1"/>
+              <a:t>baš</a:t>
+            </a:r>
+            <a:r>
+              <a:rPr lang="en-US" b="0" dirty="0"/>
+              <a:t> </a:t>
+            </a:r>
+            <a:r>
+              <a:rPr lang="en-US" b="0" dirty="0" err="1"/>
+              <a:t>PyTorch</a:t>
+            </a:r>
+            <a:r>
+              <a:rPr lang="en-US" b="0" dirty="0"/>
+              <a:t> </a:t>
+            </a:r>
+            <a:r>
+              <a:rPr lang="en-US" b="0" dirty="0" err="1"/>
+              <a:t>i</a:t>
+            </a:r>
+            <a:r>
+              <a:rPr lang="en-US" b="0" dirty="0"/>
+              <a:t> </a:t>
+            </a:r>
+            <a:r>
+              <a:rPr lang="en-US" b="0" dirty="0" err="1"/>
+              <a:t>TorchSharp</a:t>
+            </a:r>
+            <a:r>
+              <a:rPr lang="en-US" b="0" dirty="0"/>
+              <a:t>?</a:t>
+            </a:r>
+            <a:br>
+              <a:rPr lang="en-US" dirty="0"/>
+            </a:br>
+            <a:r>
+              <a:rPr lang="en-US" dirty="0" err="1"/>
+              <a:t>Implementacija</a:t>
+            </a:r>
+            <a:r>
+              <a:rPr lang="en-US" dirty="0"/>
+              <a:t> je </a:t>
+            </a:r>
+            <a:r>
+              <a:rPr lang="en-US" dirty="0" err="1"/>
+              <a:t>bila</a:t>
+            </a:r>
+            <a:r>
+              <a:rPr lang="en-US" dirty="0"/>
+              <a:t> </a:t>
+            </a:r>
+            <a:r>
+              <a:rPr lang="en-US" dirty="0" err="1"/>
+              <a:t>moguća</a:t>
+            </a:r>
+            <a:r>
+              <a:rPr lang="en-US" dirty="0"/>
+              <a:t> </a:t>
+            </a:r>
+            <a:r>
+              <a:rPr lang="en-US" dirty="0" err="1"/>
+              <a:t>i</a:t>
+            </a:r>
+            <a:r>
+              <a:rPr lang="en-US" dirty="0"/>
+              <a:t> u </a:t>
+            </a:r>
+            <a:r>
+              <a:rPr lang="en-US" dirty="0" err="1"/>
+              <a:t>drugim</a:t>
+            </a:r>
+            <a:r>
+              <a:rPr lang="en-US" dirty="0"/>
+              <a:t> </a:t>
+            </a:r>
+            <a:r>
+              <a:rPr lang="en-US" dirty="0" err="1"/>
+              <a:t>bibliotekama</a:t>
+            </a:r>
+            <a:r>
+              <a:rPr lang="en-US" dirty="0"/>
+              <a:t>, </a:t>
+            </a:r>
+            <a:r>
+              <a:rPr lang="en-US" dirty="0" err="1"/>
+              <a:t>poput</a:t>
+            </a:r>
+            <a:r>
+              <a:rPr lang="en-US" dirty="0"/>
+              <a:t> TensorFlow.NET, </a:t>
+            </a:r>
+            <a:r>
+              <a:rPr lang="en-US" dirty="0" err="1"/>
+              <a:t>ali</a:t>
+            </a:r>
+            <a:r>
+              <a:rPr lang="en-US" dirty="0"/>
+              <a:t> </a:t>
+            </a:r>
+            <a:r>
+              <a:rPr lang="en-US" dirty="0" err="1"/>
+              <a:t>TorchSharp</a:t>
+            </a:r>
+            <a:r>
+              <a:rPr lang="en-US" dirty="0"/>
+              <a:t> se </a:t>
+            </a:r>
+            <a:r>
+              <a:rPr lang="en-US" dirty="0" err="1"/>
+              <a:t>pokazao</a:t>
+            </a:r>
+            <a:r>
+              <a:rPr lang="en-US" dirty="0"/>
+              <a:t> </a:t>
+            </a:r>
+            <a:r>
+              <a:rPr lang="en-US" dirty="0" err="1"/>
+              <a:t>kao</a:t>
+            </a:r>
+            <a:r>
+              <a:rPr lang="en-US" dirty="0"/>
+              <a:t> </a:t>
+            </a:r>
+            <a:r>
+              <a:rPr lang="en-US" dirty="0" err="1"/>
+              <a:t>najbolja</a:t>
+            </a:r>
+            <a:r>
+              <a:rPr lang="en-US" dirty="0"/>
+              <a:t> </a:t>
+            </a:r>
+            <a:r>
+              <a:rPr lang="en-US" dirty="0" err="1"/>
+              <a:t>opcija</a:t>
+            </a:r>
+            <a:r>
+              <a:rPr lang="en-US" dirty="0"/>
+              <a:t> </a:t>
+            </a:r>
+            <a:r>
+              <a:rPr lang="en-US" dirty="0" err="1"/>
+              <a:t>jer</a:t>
+            </a:r>
+            <a:r>
+              <a:rPr lang="en-US" dirty="0"/>
+              <a:t> </a:t>
+            </a:r>
+            <a:r>
+              <a:rPr lang="en-US" dirty="0" err="1"/>
+              <a:t>omogućava</a:t>
+            </a:r>
+            <a:r>
+              <a:rPr lang="en-US" dirty="0"/>
+              <a:t> </a:t>
+            </a:r>
+            <a:r>
+              <a:rPr lang="en-US" dirty="0" err="1"/>
+              <a:t>direktnu</a:t>
+            </a:r>
+            <a:r>
+              <a:rPr lang="en-US" dirty="0"/>
+              <a:t> </a:t>
+            </a:r>
+            <a:r>
+              <a:rPr lang="en-US" dirty="0" err="1"/>
+              <a:t>implementaciju</a:t>
+            </a:r>
+            <a:r>
+              <a:rPr lang="en-US" dirty="0"/>
+              <a:t> </a:t>
+            </a:r>
+            <a:r>
+              <a:rPr lang="en-US" dirty="0" err="1"/>
+              <a:t>neuronske</a:t>
+            </a:r>
+            <a:r>
+              <a:rPr lang="en-US" dirty="0"/>
+              <a:t> </a:t>
+            </a:r>
+            <a:r>
+              <a:rPr lang="en-US" dirty="0" err="1"/>
+              <a:t>mreže</a:t>
+            </a:r>
+            <a:r>
+              <a:rPr lang="en-US" dirty="0"/>
+              <a:t> </a:t>
+            </a:r>
+            <a:r>
+              <a:rPr lang="en-US" dirty="0" err="1"/>
+              <a:t>preko</a:t>
+            </a:r>
+            <a:r>
+              <a:rPr lang="en-US" dirty="0"/>
+              <a:t> </a:t>
+            </a:r>
+            <a:r>
+              <a:rPr lang="en-US" dirty="0" err="1"/>
+              <a:t>slojeva</a:t>
+            </a:r>
+            <a:r>
+              <a:rPr lang="en-US" dirty="0"/>
+              <a:t>, </a:t>
+            </a:r>
+            <a:r>
+              <a:rPr lang="en-US" dirty="0" err="1"/>
+              <a:t>vrlo</a:t>
+            </a:r>
+            <a:r>
+              <a:rPr lang="en-US" dirty="0"/>
+              <a:t> </a:t>
+            </a:r>
+            <a:r>
+              <a:rPr lang="en-US" dirty="0" err="1"/>
+              <a:t>slično</a:t>
+            </a:r>
+            <a:r>
+              <a:rPr lang="en-US" dirty="0"/>
+              <a:t> </a:t>
+            </a:r>
+            <a:r>
+              <a:rPr lang="en-US" dirty="0" err="1"/>
+              <a:t>kao</a:t>
+            </a:r>
+            <a:r>
+              <a:rPr lang="en-US" dirty="0"/>
+              <a:t> </a:t>
+            </a:r>
+            <a:r>
+              <a:rPr lang="en-US" dirty="0" err="1"/>
+              <a:t>i</a:t>
+            </a:r>
+            <a:r>
+              <a:rPr lang="en-US" dirty="0"/>
+              <a:t> </a:t>
+            </a:r>
+            <a:r>
+              <a:rPr lang="en-US" dirty="0" err="1"/>
+              <a:t>PyTorch</a:t>
+            </a:r>
+            <a:r>
+              <a:rPr lang="en-US" dirty="0"/>
+              <a:t>.</a:t>
+            </a:r>
+          </a:p>
+          <a:p>
+            <a:r>
+              <a:rPr lang="en-US" dirty="0"/>
+              <a:t>Da li </a:t>
+            </a:r>
+            <a:r>
+              <a:rPr lang="en-US" dirty="0" err="1"/>
+              <a:t>postoje</a:t>
+            </a:r>
+            <a:r>
+              <a:rPr lang="en-US" dirty="0"/>
+              <a:t> wrapper za </a:t>
+            </a:r>
+            <a:r>
+              <a:rPr lang="en-US" dirty="0" err="1"/>
+              <a:t>LibTorch</a:t>
+            </a:r>
+            <a:r>
+              <a:rPr lang="en-US" dirty="0"/>
+              <a:t> u </a:t>
+            </a:r>
+            <a:r>
+              <a:rPr lang="en-US" dirty="0" err="1"/>
+              <a:t>drugim</a:t>
+            </a:r>
+            <a:r>
+              <a:rPr lang="en-US" dirty="0"/>
+              <a:t> </a:t>
+            </a:r>
+            <a:r>
+              <a:rPr lang="en-US" dirty="0" err="1"/>
+              <a:t>jezicima</a:t>
+            </a:r>
+            <a:r>
+              <a:rPr lang="en-US" dirty="0"/>
+              <a:t>?</a:t>
+            </a:r>
+          </a:p>
+          <a:p>
+            <a:endParaRPr lang="en-US" dirty="0"/>
+          </a:p>
+          <a:p>
+            <a:r>
+              <a:rPr lang="pl-PL" b="0" dirty="0"/>
+              <a:t>Postoje li omotači za LibTorch u drugim jezicima?</a:t>
+            </a:r>
+            <a:br>
+              <a:rPr lang="en-US" dirty="0"/>
+            </a:br>
+            <a:r>
+              <a:rPr lang="en-US" dirty="0"/>
+              <a:t>Da, </a:t>
+            </a:r>
+            <a:r>
+              <a:rPr lang="en-US" dirty="0" err="1"/>
+              <a:t>postoje</a:t>
+            </a:r>
+            <a:r>
+              <a:rPr lang="en-US" dirty="0"/>
+              <a:t> — u </a:t>
+            </a:r>
+            <a:r>
+              <a:rPr lang="en-US" dirty="0" err="1"/>
+              <a:t>Javi</a:t>
+            </a:r>
+            <a:r>
+              <a:rPr lang="en-US" dirty="0"/>
+              <a:t>, </a:t>
+            </a:r>
+            <a:r>
+              <a:rPr lang="en-US" dirty="0" err="1"/>
+              <a:t>Rustu</a:t>
+            </a:r>
+            <a:r>
+              <a:rPr lang="en-US" dirty="0"/>
+              <a:t> (tch-</a:t>
+            </a:r>
+            <a:r>
+              <a:rPr lang="en-US" dirty="0" err="1"/>
+              <a:t>rs</a:t>
+            </a:r>
+            <a:r>
+              <a:rPr lang="en-US" dirty="0"/>
+              <a:t>), </a:t>
+            </a:r>
+            <a:r>
+              <a:rPr lang="en-US" dirty="0" err="1"/>
+              <a:t>JavaScriptu</a:t>
+            </a:r>
+            <a:r>
+              <a:rPr lang="en-US" dirty="0"/>
+              <a:t>. </a:t>
+            </a:r>
+            <a:r>
+              <a:rPr lang="en-US" dirty="0" err="1"/>
+              <a:t>Kako</a:t>
+            </a:r>
+            <a:r>
+              <a:rPr lang="en-US" dirty="0"/>
+              <a:t> je </a:t>
+            </a:r>
+            <a:r>
+              <a:rPr lang="en-US" dirty="0" err="1"/>
+              <a:t>pozadinska</a:t>
+            </a:r>
+            <a:r>
+              <a:rPr lang="en-US" dirty="0"/>
+              <a:t> </a:t>
+            </a:r>
+            <a:r>
+              <a:rPr lang="en-US" dirty="0" err="1"/>
+              <a:t>logika</a:t>
+            </a:r>
+            <a:r>
+              <a:rPr lang="en-US" dirty="0"/>
+              <a:t> </a:t>
+            </a:r>
+            <a:r>
+              <a:rPr lang="en-US" dirty="0" err="1"/>
+              <a:t>ista</a:t>
+            </a:r>
+            <a:r>
+              <a:rPr lang="en-US" dirty="0"/>
+              <a:t>, </a:t>
+            </a:r>
+            <a:r>
+              <a:rPr lang="en-US" dirty="0" err="1"/>
+              <a:t>omotač</a:t>
+            </a:r>
+            <a:r>
+              <a:rPr lang="en-US" dirty="0"/>
+              <a:t> </a:t>
+            </a:r>
+            <a:r>
+              <a:rPr lang="en-US" dirty="0" err="1"/>
+              <a:t>može</a:t>
+            </a:r>
+            <a:r>
+              <a:rPr lang="en-US" dirty="0"/>
+              <a:t> </a:t>
+            </a:r>
+            <a:r>
+              <a:rPr lang="en-US" dirty="0" err="1"/>
+              <a:t>biti</a:t>
+            </a:r>
+            <a:r>
+              <a:rPr lang="en-US" dirty="0"/>
+              <a:t> </a:t>
+            </a:r>
+            <a:r>
+              <a:rPr lang="en-US" dirty="0" err="1"/>
+              <a:t>napisan</a:t>
+            </a:r>
+            <a:r>
+              <a:rPr lang="en-US" dirty="0"/>
+              <a:t> u </a:t>
+            </a:r>
+            <a:r>
+              <a:rPr lang="en-US" dirty="0" err="1"/>
+              <a:t>bilo</a:t>
+            </a:r>
+            <a:r>
+              <a:rPr lang="en-US" dirty="0"/>
+              <a:t> </a:t>
+            </a:r>
+            <a:r>
+              <a:rPr lang="en-US" dirty="0" err="1"/>
+              <a:t>kojem</a:t>
+            </a:r>
+            <a:r>
+              <a:rPr lang="en-US" dirty="0"/>
+              <a:t> </a:t>
+            </a:r>
+            <a:r>
+              <a:rPr lang="en-US" dirty="0" err="1"/>
+              <a:t>programskom</a:t>
+            </a:r>
+            <a:r>
+              <a:rPr lang="en-US" dirty="0"/>
+              <a:t> </a:t>
+            </a:r>
+            <a:r>
+              <a:rPr lang="en-US" dirty="0" err="1"/>
+              <a:t>jeziku</a:t>
+            </a:r>
+            <a:r>
+              <a:rPr lang="en-US" dirty="0"/>
+              <a:t>.</a:t>
+            </a:r>
+          </a:p>
+        </p:txBody>
+      </p:sp>
+      <p:sp>
+        <p:nvSpPr>
+          <p:cNvPr id="4" name="Slide Number Placeholder 3"/>
+          <p:cNvSpPr>
+            <a:spLocks noGrp="1"/>
+          </p:cNvSpPr>
+          <p:nvPr>
+            <p:ph type="sldNum" sz="quarter" idx="5"/>
+          </p:nvPr>
+        </p:nvSpPr>
+        <p:spPr/>
+        <p:txBody>
+          <a:bodyPr/>
+          <a:lstStyle/>
+          <a:p>
+            <a:fld id="{9200A785-91A4-4858-91F9-18C65D64E1E0}" type="slidenum">
+              <a:rPr lang="en-US" smtClean="0"/>
+              <a:t>4</a:t>
+            </a:fld>
+            <a:endParaRPr lang="en-US"/>
+          </a:p>
+        </p:txBody>
+      </p:sp>
+    </p:spTree>
+    <p:extLst>
+      <p:ext uri="{BB962C8B-B14F-4D97-AF65-F5344CB8AC3E}">
+        <p14:creationId xmlns:p14="http://schemas.microsoft.com/office/powerpoint/2010/main" val="355107787"/>
+      </p:ext>
+    </p:extLst>
+  </p:cSld>
+  <p:clrMapOvr>
+    <a:masterClrMapping/>
+  </p:clrMapOvr>
+</p:notes>
+</file>
+
+<file path=ppt/notesSlides/notesSlide4.xml><?xml version="1.0" encoding="utf-8"?>
+<p:notes xmlns:a="http://schemas.openxmlformats.org/drawingml/2006/main" xmlns:r="http://schemas.openxmlformats.org/officeDocument/2006/relationships" xmlns:p="http://schemas.openxmlformats.org/presentationml/2006/main">
+  <p:cSld>
+    <p:spTree>
+      <p:nvGrpSpPr>
+        <p:cNvPr id="1" name=""/>
+        <p:cNvGrpSpPr/>
+        <p:nvPr/>
+      </p:nvGrpSpPr>
+      <p:grpSpPr>
+        <a:xfrm>
+          <a:off x="0" y="0"/>
+          <a:ext cx="0" cy="0"/>
+          <a:chOff x="0" y="0"/>
+          <a:chExt cx="0" cy="0"/>
+        </a:xfrm>
+      </p:grpSpPr>
+      <p:sp>
+        <p:nvSpPr>
+          <p:cNvPr id="2" name="Slide Image Placeholder 1"/>
+          <p:cNvSpPr>
+            <a:spLocks noGrp="1" noRot="1" noChangeAspect="1"/>
+          </p:cNvSpPr>
+          <p:nvPr>
+            <p:ph type="sldImg"/>
+          </p:nvPr>
+        </p:nvSpPr>
+        <p:spPr/>
+      </p:sp>
+      <p:sp>
+        <p:nvSpPr>
+          <p:cNvPr id="3" name="Notes Placeholder 2"/>
+          <p:cNvSpPr>
+            <a:spLocks noGrp="1"/>
+          </p:cNvSpPr>
+          <p:nvPr>
+            <p:ph type="body" idx="1"/>
+          </p:nvPr>
+        </p:nvSpPr>
+        <p:spPr/>
+        <p:txBody>
+          <a:bodyPr/>
+          <a:lstStyle/>
+          <a:p>
+            <a:pPr rtl="0"/>
+            <a:r>
+              <a:rPr lang="en-US" b="1" dirty="0" err="1"/>
+              <a:t>Kako</a:t>
+            </a:r>
+            <a:r>
+              <a:rPr lang="en-US" b="1" dirty="0"/>
+              <a:t> je </a:t>
+            </a:r>
+            <a:r>
+              <a:rPr lang="en-US" b="1" dirty="0" err="1"/>
+              <a:t>izdvojeno</a:t>
+            </a:r>
+            <a:r>
+              <a:rPr lang="en-US" b="1" dirty="0"/>
+              <a:t> </a:t>
+            </a:r>
+            <a:r>
+              <a:rPr lang="en-US" b="1" dirty="0" err="1"/>
+              <a:t>tih</a:t>
+            </a:r>
+            <a:r>
+              <a:rPr lang="en-US" b="1" dirty="0"/>
+              <a:t> 1097  </a:t>
+            </a:r>
+            <a:r>
+              <a:rPr lang="en-US" b="1" dirty="0" err="1"/>
+              <a:t>slika</a:t>
+            </a:r>
+            <a:r>
+              <a:rPr lang="en-US" b="1" dirty="0"/>
+              <a:t>?</a:t>
+            </a:r>
+            <a:br>
+              <a:rPr lang="en-US" dirty="0"/>
+            </a:br>
+            <a:r>
+              <a:rPr lang="en-US" dirty="0" err="1"/>
+              <a:t>Svaki</a:t>
+            </a:r>
+            <a:r>
+              <a:rPr lang="en-US" dirty="0"/>
+              <a:t> </a:t>
+            </a:r>
+            <a:r>
+              <a:rPr lang="en-US" dirty="0" err="1"/>
+              <a:t>slučaj</a:t>
+            </a:r>
+            <a:r>
+              <a:rPr lang="en-US" dirty="0"/>
+              <a:t> </a:t>
+            </a:r>
+            <a:r>
+              <a:rPr lang="en-US" dirty="0" err="1"/>
+              <a:t>predstavlja</a:t>
+            </a:r>
+            <a:r>
+              <a:rPr lang="en-US" dirty="0"/>
+              <a:t> </a:t>
+            </a:r>
+            <a:r>
+              <a:rPr lang="en-US" dirty="0" err="1"/>
+              <a:t>jednog</a:t>
+            </a:r>
+            <a:r>
+              <a:rPr lang="en-US" dirty="0"/>
+              <a:t> </a:t>
+            </a:r>
+            <a:r>
+              <a:rPr lang="en-US" dirty="0" err="1"/>
+              <a:t>pacijenta</a:t>
+            </a:r>
+            <a:r>
+              <a:rPr lang="en-US" dirty="0"/>
+              <a:t>, a </a:t>
+            </a:r>
+            <a:r>
+              <a:rPr lang="en-US" dirty="0" err="1"/>
+              <a:t>svaki</a:t>
+            </a:r>
+            <a:r>
+              <a:rPr lang="en-US" dirty="0"/>
+              <a:t> </a:t>
+            </a:r>
+            <a:r>
+              <a:rPr lang="en-US" dirty="0" err="1"/>
+              <a:t>snimak</a:t>
+            </a:r>
+            <a:r>
+              <a:rPr lang="en-US" dirty="0"/>
+              <a:t> </a:t>
+            </a:r>
+            <a:r>
+              <a:rPr lang="en-US" dirty="0" err="1"/>
+              <a:t>sadrži</a:t>
+            </a:r>
+            <a:r>
+              <a:rPr lang="en-US" dirty="0"/>
+              <a:t> </a:t>
+            </a:r>
+            <a:r>
+              <a:rPr lang="en-US" dirty="0" err="1"/>
+              <a:t>veliki</a:t>
+            </a:r>
+            <a:r>
+              <a:rPr lang="en-US" dirty="0"/>
+              <a:t> </a:t>
+            </a:r>
+            <a:r>
+              <a:rPr lang="en-US" dirty="0" err="1"/>
+              <a:t>broj</a:t>
+            </a:r>
+            <a:r>
+              <a:rPr lang="en-US" dirty="0"/>
+              <a:t> </a:t>
+            </a:r>
+            <a:r>
+              <a:rPr lang="en-US" dirty="0" err="1"/>
+              <a:t>slojeva</a:t>
+            </a:r>
+            <a:r>
+              <a:rPr lang="en-US" dirty="0"/>
+              <a:t> </a:t>
+            </a:r>
+            <a:r>
+              <a:rPr lang="en-US" dirty="0" err="1"/>
+              <a:t>grudnog</a:t>
+            </a:r>
+            <a:r>
+              <a:rPr lang="en-US" dirty="0"/>
+              <a:t> </a:t>
+            </a:r>
+            <a:r>
+              <a:rPr lang="en-US" dirty="0" err="1"/>
+              <a:t>koša</a:t>
+            </a:r>
+            <a:r>
+              <a:rPr lang="en-US" dirty="0"/>
+              <a:t>. </a:t>
+            </a:r>
+            <a:r>
+              <a:rPr lang="en-US" dirty="0" err="1"/>
+              <a:t>Većina</a:t>
+            </a:r>
+            <a:r>
+              <a:rPr lang="en-US" dirty="0"/>
+              <a:t> </a:t>
+            </a:r>
+            <a:r>
+              <a:rPr lang="en-US" dirty="0" err="1"/>
+              <a:t>slojeva</a:t>
+            </a:r>
+            <a:r>
+              <a:rPr lang="en-US" dirty="0"/>
+              <a:t> ne </a:t>
+            </a:r>
+            <a:r>
+              <a:rPr lang="en-US" dirty="0" err="1"/>
+              <a:t>prikazuje</a:t>
+            </a:r>
+            <a:r>
+              <a:rPr lang="en-US" dirty="0"/>
+              <a:t> </a:t>
+            </a:r>
+            <a:r>
+              <a:rPr lang="en-US" dirty="0" err="1"/>
+              <a:t>relevantnu</a:t>
+            </a:r>
+            <a:r>
+              <a:rPr lang="en-US" dirty="0"/>
+              <a:t> </a:t>
+            </a:r>
+            <a:r>
+              <a:rPr lang="en-US" dirty="0" err="1"/>
+              <a:t>informaciju</a:t>
+            </a:r>
+            <a:r>
+              <a:rPr lang="en-US" dirty="0"/>
+              <a:t>, pa </a:t>
+            </a:r>
+            <a:r>
+              <a:rPr lang="en-US" dirty="0" err="1"/>
+              <a:t>su</a:t>
+            </a:r>
+            <a:r>
+              <a:rPr lang="en-US" dirty="0"/>
+              <a:t> </a:t>
+            </a:r>
+            <a:r>
+              <a:rPr lang="en-US" dirty="0" err="1"/>
+              <a:t>autori</a:t>
+            </a:r>
+            <a:r>
+              <a:rPr lang="en-US" dirty="0"/>
+              <a:t> </a:t>
+            </a:r>
+            <a:r>
+              <a:rPr lang="en-US" dirty="0" err="1"/>
+              <a:t>skupa</a:t>
+            </a:r>
+            <a:r>
+              <a:rPr lang="en-US" dirty="0"/>
+              <a:t> </a:t>
+            </a:r>
+            <a:r>
+              <a:rPr lang="en-US" dirty="0" err="1"/>
+              <a:t>izdvojili</a:t>
+            </a:r>
+            <a:r>
+              <a:rPr lang="en-US" dirty="0"/>
+              <a:t> one </a:t>
+            </a:r>
+            <a:r>
+              <a:rPr lang="en-US" dirty="0" err="1"/>
+              <a:t>na</a:t>
+            </a:r>
+            <a:r>
+              <a:rPr lang="en-US" dirty="0"/>
+              <a:t> </a:t>
+            </a:r>
+            <a:r>
+              <a:rPr lang="en-US" dirty="0" err="1"/>
+              <a:t>kojima</a:t>
+            </a:r>
+            <a:r>
+              <a:rPr lang="en-US" dirty="0"/>
+              <a:t> je </a:t>
+            </a:r>
+            <a:r>
+              <a:rPr lang="en-US" dirty="0" err="1"/>
+              <a:t>nalaz</a:t>
+            </a:r>
+            <a:r>
+              <a:rPr lang="en-US" dirty="0"/>
+              <a:t> </a:t>
+            </a:r>
+            <a:r>
+              <a:rPr lang="en-US" dirty="0" err="1"/>
+              <a:t>vidljiv</a:t>
+            </a:r>
+            <a:r>
+              <a:rPr lang="en-US" dirty="0"/>
+              <a:t>. </a:t>
+            </a:r>
+            <a:r>
+              <a:rPr lang="en-US" dirty="0" err="1"/>
+              <a:t>Selekciju</a:t>
+            </a:r>
+            <a:r>
+              <a:rPr lang="en-US" dirty="0"/>
+              <a:t> </a:t>
+            </a:r>
+            <a:r>
+              <a:rPr lang="en-US" dirty="0" err="1"/>
+              <a:t>su</a:t>
+            </a:r>
+            <a:r>
+              <a:rPr lang="en-US" dirty="0"/>
+              <a:t>, </a:t>
+            </a:r>
+            <a:r>
+              <a:rPr lang="en-US" dirty="0" err="1"/>
+              <a:t>dakle</a:t>
+            </a:r>
+            <a:r>
+              <a:rPr lang="en-US" dirty="0"/>
+              <a:t>, </a:t>
+            </a:r>
+            <a:r>
+              <a:rPr lang="en-US" dirty="0" err="1"/>
+              <a:t>izvršili</a:t>
+            </a:r>
+            <a:r>
+              <a:rPr lang="en-US" dirty="0"/>
+              <a:t> </a:t>
+            </a:r>
+            <a:r>
+              <a:rPr lang="en-US" dirty="0" err="1"/>
+              <a:t>autori</a:t>
+            </a:r>
+            <a:r>
+              <a:rPr lang="en-US" dirty="0"/>
+              <a:t> </a:t>
+            </a:r>
+            <a:r>
+              <a:rPr lang="en-US" dirty="0" err="1"/>
+              <a:t>skupa</a:t>
+            </a:r>
+            <a:r>
+              <a:rPr lang="en-US" dirty="0"/>
+              <a:t>, ne ja.</a:t>
+            </a:r>
+          </a:p>
+          <a:p>
+            <a:pPr rtl="0"/>
+            <a:endParaRPr lang="en-US" b="1" dirty="0"/>
+          </a:p>
+          <a:p>
+            <a:pPr rtl="0"/>
+            <a:r>
+              <a:rPr lang="en-US" b="1" dirty="0" err="1"/>
+              <a:t>Zašto</a:t>
+            </a:r>
+            <a:r>
+              <a:rPr lang="en-US" b="1" dirty="0"/>
+              <a:t> </a:t>
+            </a:r>
+            <a:r>
+              <a:rPr lang="en-US" b="1" dirty="0" err="1"/>
+              <a:t>baš</a:t>
+            </a:r>
+            <a:r>
+              <a:rPr lang="en-US" b="1" dirty="0"/>
+              <a:t> </a:t>
+            </a:r>
+            <a:r>
+              <a:rPr lang="en-US" b="1" dirty="0" err="1"/>
+              <a:t>ovaj</a:t>
+            </a:r>
+            <a:r>
+              <a:rPr lang="en-US" b="1" dirty="0"/>
+              <a:t> </a:t>
+            </a:r>
+            <a:r>
+              <a:rPr lang="en-US" b="1" dirty="0" err="1"/>
+              <a:t>skup</a:t>
+            </a:r>
+            <a:r>
+              <a:rPr lang="en-US" b="1" dirty="0"/>
+              <a:t> </a:t>
+            </a:r>
+            <a:r>
+              <a:rPr lang="en-US" b="1" dirty="0" err="1"/>
+              <a:t>podataka</a:t>
+            </a:r>
+            <a:r>
+              <a:rPr lang="en-US" b="1" dirty="0"/>
+              <a:t>?</a:t>
+            </a:r>
+            <a:br>
+              <a:rPr lang="en-US" dirty="0"/>
+            </a:br>
+            <a:r>
+              <a:rPr lang="en-US" dirty="0"/>
+              <a:t>Kaggle </a:t>
+            </a:r>
+            <a:r>
+              <a:rPr lang="en-US" dirty="0" err="1"/>
+              <a:t>nudi</a:t>
+            </a:r>
+            <a:r>
+              <a:rPr lang="en-US" dirty="0"/>
+              <a:t> </a:t>
+            </a:r>
+            <a:r>
+              <a:rPr lang="en-US" dirty="0" err="1"/>
+              <a:t>veliki</a:t>
+            </a:r>
+            <a:r>
+              <a:rPr lang="en-US" dirty="0"/>
+              <a:t> </a:t>
+            </a:r>
+            <a:r>
+              <a:rPr lang="en-US" dirty="0" err="1"/>
+              <a:t>broj</a:t>
+            </a:r>
+            <a:r>
+              <a:rPr lang="en-US" dirty="0"/>
+              <a:t> </a:t>
+            </a:r>
+            <a:r>
+              <a:rPr lang="en-US" dirty="0" err="1"/>
+              <a:t>skupova</a:t>
+            </a:r>
+            <a:r>
+              <a:rPr lang="en-US" dirty="0"/>
+              <a:t> </a:t>
+            </a:r>
+            <a:r>
+              <a:rPr lang="en-US" dirty="0" err="1"/>
+              <a:t>podataka</a:t>
+            </a:r>
+            <a:r>
+              <a:rPr lang="en-US" dirty="0"/>
+              <a:t>. </a:t>
+            </a:r>
+            <a:r>
+              <a:rPr lang="en-US" dirty="0" err="1"/>
+              <a:t>Ovaj</a:t>
+            </a:r>
+            <a:r>
+              <a:rPr lang="en-US" dirty="0"/>
+              <a:t> je </a:t>
+            </a:r>
+            <a:r>
+              <a:rPr lang="en-US" dirty="0" err="1"/>
+              <a:t>odabran</a:t>
+            </a:r>
+            <a:r>
+              <a:rPr lang="en-US" dirty="0"/>
+              <a:t> </a:t>
+            </a:r>
+            <a:r>
+              <a:rPr lang="en-US" dirty="0" err="1"/>
+              <a:t>jer</a:t>
+            </a:r>
+            <a:r>
+              <a:rPr lang="en-US" dirty="0"/>
+              <a:t> </a:t>
+            </a:r>
+            <a:r>
+              <a:rPr lang="en-US" dirty="0" err="1"/>
+              <a:t>postoji</a:t>
+            </a:r>
+            <a:r>
+              <a:rPr lang="en-US" dirty="0"/>
+              <a:t> </a:t>
+            </a:r>
+            <a:r>
+              <a:rPr lang="en-US" dirty="0" err="1"/>
+              <a:t>mnogo</a:t>
+            </a:r>
+            <a:r>
+              <a:rPr lang="en-US" dirty="0"/>
+              <a:t> </a:t>
+            </a:r>
+            <a:r>
+              <a:rPr lang="en-US" dirty="0" err="1"/>
+              <a:t>objavljenih</a:t>
+            </a:r>
+            <a:r>
+              <a:rPr lang="en-US" dirty="0"/>
+              <a:t> </a:t>
+            </a:r>
+            <a:r>
+              <a:rPr lang="en-US" dirty="0" err="1"/>
+              <a:t>implementacija</a:t>
+            </a:r>
+            <a:r>
+              <a:rPr lang="en-US" dirty="0"/>
+              <a:t> CNN </a:t>
+            </a:r>
+            <a:r>
+              <a:rPr lang="en-US" dirty="0" err="1"/>
+              <a:t>mreža</a:t>
+            </a:r>
+            <a:r>
+              <a:rPr lang="en-US" dirty="0"/>
+              <a:t> </a:t>
+            </a:r>
+            <a:r>
+              <a:rPr lang="en-US" dirty="0" err="1"/>
+              <a:t>nad</a:t>
+            </a:r>
+            <a:r>
+              <a:rPr lang="en-US" dirty="0"/>
+              <a:t> </a:t>
+            </a:r>
+            <a:r>
+              <a:rPr lang="en-US" dirty="0" err="1"/>
+              <a:t>njim</a:t>
+            </a:r>
+            <a:r>
+              <a:rPr lang="en-US" dirty="0"/>
+              <a:t>, pa je </a:t>
+            </a:r>
+            <a:r>
+              <a:rPr lang="en-US" dirty="0" err="1"/>
+              <a:t>mogao</a:t>
+            </a:r>
+            <a:r>
+              <a:rPr lang="en-US" dirty="0"/>
+              <a:t> </a:t>
+            </a:r>
+            <a:r>
+              <a:rPr lang="en-US" dirty="0" err="1"/>
+              <a:t>poslužiti</a:t>
+            </a:r>
+            <a:r>
+              <a:rPr lang="en-US" dirty="0"/>
+              <a:t> </a:t>
+            </a:r>
+            <a:r>
+              <a:rPr lang="en-US" dirty="0" err="1"/>
+              <a:t>i</a:t>
+            </a:r>
+            <a:r>
+              <a:rPr lang="en-US" dirty="0"/>
+              <a:t> </a:t>
+            </a:r>
+            <a:r>
+              <a:rPr lang="en-US" dirty="0" err="1"/>
+              <a:t>kao</a:t>
+            </a:r>
+            <a:r>
+              <a:rPr lang="en-US" dirty="0"/>
+              <a:t> </a:t>
+            </a:r>
+            <a:r>
+              <a:rPr lang="en-US" dirty="0" err="1"/>
+              <a:t>provjera</a:t>
+            </a:r>
+            <a:r>
+              <a:rPr lang="en-US" dirty="0"/>
+              <a:t> da </a:t>
+            </a:r>
+            <a:r>
+              <a:rPr lang="en-US" dirty="0" err="1"/>
+              <a:t>su</a:t>
+            </a:r>
+            <a:r>
+              <a:rPr lang="en-US" dirty="0"/>
+              <a:t> </a:t>
+            </a:r>
+            <a:r>
+              <a:rPr lang="en-US" dirty="0" err="1"/>
+              <a:t>moji</a:t>
+            </a:r>
+            <a:r>
+              <a:rPr lang="en-US" dirty="0"/>
+              <a:t> </a:t>
+            </a:r>
+            <a:r>
+              <a:rPr lang="en-US" dirty="0" err="1"/>
+              <a:t>rezultati</a:t>
+            </a:r>
+            <a:r>
+              <a:rPr lang="en-US" dirty="0"/>
+              <a:t> u </a:t>
+            </a:r>
+            <a:r>
+              <a:rPr lang="en-US" dirty="0" err="1"/>
+              <a:t>očekivanom</a:t>
+            </a:r>
+            <a:r>
+              <a:rPr lang="en-US" dirty="0"/>
+              <a:t> </a:t>
+            </a:r>
+            <a:r>
+              <a:rPr lang="en-US" dirty="0" err="1"/>
+              <a:t>rasponu</a:t>
+            </a:r>
+            <a:r>
+              <a:rPr lang="en-US" dirty="0"/>
+              <a:t>.</a:t>
+            </a:r>
+          </a:p>
+          <a:p>
+            <a:pPr rtl="0"/>
+            <a:endParaRPr lang="en-US" dirty="0"/>
+          </a:p>
+          <a:p>
+            <a:pPr rtl="0"/>
+            <a:r>
+              <a:rPr lang="en-US" b="1" dirty="0"/>
+              <a:t>Koliko </a:t>
+            </a:r>
+            <a:r>
+              <a:rPr lang="en-US" b="1" dirty="0" err="1"/>
+              <a:t>ima</a:t>
+            </a:r>
+            <a:r>
+              <a:rPr lang="en-US" b="1" dirty="0"/>
+              <a:t> </a:t>
+            </a:r>
+            <a:r>
+              <a:rPr lang="en-US" b="1" dirty="0" err="1"/>
+              <a:t>slika</a:t>
+            </a:r>
+            <a:r>
+              <a:rPr lang="en-US" b="1" dirty="0"/>
+              <a:t> po </a:t>
+            </a:r>
+            <a:r>
+              <a:rPr lang="en-US" b="1" dirty="0" err="1"/>
+              <a:t>klasi</a:t>
+            </a:r>
+            <a:r>
+              <a:rPr lang="en-US" b="1" dirty="0"/>
+              <a:t>?</a:t>
+            </a:r>
+          </a:p>
+          <a:p>
+            <a:pPr rtl="0"/>
+            <a:r>
+              <a:rPr lang="en-US" dirty="0" err="1"/>
+              <a:t>Imamo</a:t>
+            </a:r>
+            <a:r>
+              <a:rPr lang="en-US" dirty="0"/>
+              <a:t>:</a:t>
+            </a:r>
+          </a:p>
+          <a:p>
+            <a:pPr rtl="0"/>
+            <a:r>
+              <a:rPr lang="en-US" dirty="0" err="1"/>
+              <a:t>Maligno</a:t>
+            </a:r>
+            <a:r>
+              <a:rPr lang="en-US" dirty="0"/>
+              <a:t>: 561 </a:t>
+            </a:r>
+            <a:r>
+              <a:rPr lang="en-US" dirty="0" err="1"/>
+              <a:t>slika</a:t>
+            </a:r>
+            <a:endParaRPr lang="en-US" dirty="0"/>
+          </a:p>
+          <a:p>
+            <a:pPr rtl="0"/>
+            <a:r>
+              <a:rPr lang="en-US" dirty="0" err="1"/>
+              <a:t>Benigno</a:t>
+            </a:r>
+            <a:r>
+              <a:rPr lang="en-US" dirty="0"/>
+              <a:t>: 120 </a:t>
+            </a:r>
+            <a:r>
+              <a:rPr lang="en-US" dirty="0" err="1"/>
+              <a:t>slika</a:t>
+            </a:r>
+            <a:endParaRPr lang="en-US" dirty="0"/>
+          </a:p>
+          <a:p>
+            <a:pPr rtl="0"/>
+            <a:r>
+              <a:rPr lang="en-US" dirty="0" err="1"/>
+              <a:t>Normalno</a:t>
+            </a:r>
+            <a:r>
+              <a:rPr lang="en-US" dirty="0"/>
+              <a:t>: 416 </a:t>
+            </a:r>
+            <a:r>
+              <a:rPr lang="en-US" dirty="0" err="1"/>
+              <a:t>slika</a:t>
+            </a:r>
+            <a:endParaRPr lang="en-US" dirty="0"/>
+          </a:p>
+          <a:p>
+            <a:pPr rtl="0"/>
+            <a:endParaRPr lang="en-US" dirty="0"/>
+          </a:p>
+        </p:txBody>
+      </p:sp>
+      <p:sp>
+        <p:nvSpPr>
+          <p:cNvPr id="4" name="Slide Number Placeholder 3"/>
+          <p:cNvSpPr>
+            <a:spLocks noGrp="1"/>
+          </p:cNvSpPr>
+          <p:nvPr>
+            <p:ph type="sldNum" sz="quarter" idx="5"/>
+          </p:nvPr>
+        </p:nvSpPr>
+        <p:spPr/>
+        <p:txBody>
+          <a:bodyPr/>
+          <a:lstStyle/>
+          <a:p>
+            <a:fld id="{9200A785-91A4-4858-91F9-18C65D64E1E0}" type="slidenum">
+              <a:rPr lang="en-US" smtClean="0"/>
+              <a:t>5</a:t>
+            </a:fld>
+            <a:endParaRPr lang="en-US"/>
+          </a:p>
+        </p:txBody>
+      </p:sp>
+    </p:spTree>
+    <p:extLst>
+      <p:ext uri="{BB962C8B-B14F-4D97-AF65-F5344CB8AC3E}">
+        <p14:creationId xmlns:p14="http://schemas.microsoft.com/office/powerpoint/2010/main" val="1222018551"/>
+      </p:ext>
+    </p:extLst>
+  </p:cSld>
+  <p:clrMapOvr>
+    <a:masterClrMapping/>
+  </p:clrMapOvr>
+</p:notes>
+</file>
+
 <file path=ppt/slideLayouts/slideLayout1.xml><?xml version="1.0" encoding="utf-8"?>
 <p:sldLayout xmlns:a="http://schemas.openxmlformats.org/drawingml/2006/main" xmlns:r="http://schemas.openxmlformats.org/officeDocument/2006/relationships" xmlns:p="http://schemas.openxmlformats.org/presentationml/2006/main" type="title" preserve="1">
   <p:cSld name="Title Slide">
@@ -2154,7 +3406,7 @@
           <a:p>
             <a:fld id="{B966B63C-CDDC-45F1-A941-1E23D4E81951}" type="datetimeFigureOut">
               <a:rPr lang="en-US" smtClean="0"/>
-              <a:t>8/17/2026</a:t>
+              <a:t>8/18/2026</a:t>
             </a:fld>
             <a:endParaRPr lang="en-US"/>
           </a:p>
@@ -2263,10 +3515,17 @@
         <p:spPr/>
         <p:txBody>
           <a:bodyPr/>
-          <a:lstStyle/>
-          <a:p>
-            <a:r>
-              <a:rPr lang="en-US"/>
+          <a:lstStyle>
+            <a:lvl1pPr>
+              <a:defRPr>
+                <a:latin typeface="Times New Roman" panose="02020603050405020304" pitchFamily="18" charset="0"/>
+                <a:cs typeface="Times New Roman" panose="02020603050405020304" pitchFamily="18" charset="0"/>
+              </a:defRPr>
+            </a:lvl1pPr>
+          </a:lstStyle>
+          <a:p>
+            <a:r>
+              <a:rPr lang="en-US" dirty="0"/>
               <a:t>Click to edit Master title style</a:t>
             </a:r>
           </a:p>
@@ -2295,35 +3554,35 @@
           <a:p>
             <a:pPr lvl="0"/>
             <a:r>
-              <a:rPr lang="en-US"/>
+              <a:rPr lang="en-US" dirty="0"/>
               <a:t>Click to edit Master text styles</a:t>
             </a:r>
           </a:p>
           <a:p>
             <a:pPr lvl="1"/>
             <a:r>
-              <a:rPr lang="en-US"/>
+              <a:rPr lang="en-US" dirty="0"/>
               <a:t>Second level</a:t>
             </a:r>
           </a:p>
           <a:p>
             <a:pPr lvl="2"/>
             <a:r>
-              <a:rPr lang="en-US"/>
+              <a:rPr lang="en-US" dirty="0"/>
               <a:t>Third level</a:t>
             </a:r>
           </a:p>
           <a:p>
             <a:pPr lvl="3"/>
             <a:r>
-              <a:rPr lang="en-US"/>
+              <a:rPr lang="en-US" dirty="0"/>
               <a:t>Fourth level</a:t>
             </a:r>
           </a:p>
           <a:p>
             <a:pPr lvl="4"/>
             <a:r>
-              <a:rPr lang="en-US"/>
+              <a:rPr lang="en-US" dirty="0"/>
               <a:t>Fifth level</a:t>
             </a:r>
           </a:p>
@@ -2352,7 +3611,7 @@
           <a:p>
             <a:fld id="{B966B63C-CDDC-45F1-A941-1E23D4E81951}" type="datetimeFigureOut">
               <a:rPr lang="en-US" smtClean="0"/>
-              <a:t>8/17/2026</a:t>
+              <a:t>8/18/2026</a:t>
             </a:fld>
             <a:endParaRPr lang="en-US"/>
           </a:p>
@@ -2560,7 +3819,7 @@
           <a:p>
             <a:fld id="{B966B63C-CDDC-45F1-A941-1E23D4E81951}" type="datetimeFigureOut">
               <a:rPr lang="en-US" smtClean="0"/>
-              <a:t>8/17/2026</a:t>
+              <a:t>8/18/2026</a:t>
             </a:fld>
             <a:endParaRPr lang="en-US"/>
           </a:p>
@@ -2669,10 +3928,17 @@
         <p:spPr/>
         <p:txBody>
           <a:bodyPr/>
-          <a:lstStyle/>
-          <a:p>
-            <a:r>
-              <a:rPr lang="en-US"/>
+          <a:lstStyle>
+            <a:lvl1pPr>
+              <a:defRPr>
+                <a:latin typeface="Times New Roman" panose="02020603050405020304" pitchFamily="18" charset="0"/>
+                <a:cs typeface="Times New Roman" panose="02020603050405020304" pitchFamily="18" charset="0"/>
+              </a:defRPr>
+            </a:lvl1pPr>
+          </a:lstStyle>
+          <a:p>
+            <a:r>
+              <a:rPr lang="en-US" dirty="0"/>
               <a:t>Click to edit Master title style</a:t>
             </a:r>
           </a:p>
@@ -2697,39 +3963,67 @@
         <p:spPr/>
         <p:txBody>
           <a:bodyPr/>
-          <a:lstStyle/>
+          <a:lstStyle>
+            <a:lvl1pPr>
+              <a:defRPr>
+                <a:latin typeface="Times New Roman" panose="02020603050405020304" pitchFamily="18" charset="0"/>
+                <a:cs typeface="Times New Roman" panose="02020603050405020304" pitchFamily="18" charset="0"/>
+              </a:defRPr>
+            </a:lvl1pPr>
+            <a:lvl2pPr>
+              <a:defRPr>
+                <a:latin typeface="Times New Roman" panose="02020603050405020304" pitchFamily="18" charset="0"/>
+                <a:cs typeface="Times New Roman" panose="02020603050405020304" pitchFamily="18" charset="0"/>
+              </a:defRPr>
+            </a:lvl2pPr>
+            <a:lvl3pPr>
+              <a:defRPr>
+                <a:latin typeface="Times New Roman" panose="02020603050405020304" pitchFamily="18" charset="0"/>
+                <a:cs typeface="Times New Roman" panose="02020603050405020304" pitchFamily="18" charset="0"/>
+              </a:defRPr>
+            </a:lvl3pPr>
+            <a:lvl4pPr>
+              <a:defRPr>
+                <a:latin typeface="Times New Roman" panose="02020603050405020304" pitchFamily="18" charset="0"/>
+                <a:cs typeface="Times New Roman" panose="02020603050405020304" pitchFamily="18" charset="0"/>
+              </a:defRPr>
+            </a:lvl4pPr>
+            <a:lvl5pPr>
+              <a:defRPr/>
+            </a:lvl5pPr>
+          </a:lstStyle>
           <a:p>
             <a:pPr lvl="0"/>
             <a:r>
-              <a:rPr lang="en-US"/>
+              <a:rPr lang="en-US" dirty="0"/>
               <a:t>Click to edit Master text styles</a:t>
             </a:r>
           </a:p>
           <a:p>
             <a:pPr lvl="1"/>
             <a:r>
-              <a:rPr lang="en-US"/>
+              <a:rPr lang="en-US" dirty="0"/>
               <a:t>Second level</a:t>
             </a:r>
           </a:p>
           <a:p>
             <a:pPr lvl="2"/>
             <a:r>
-              <a:rPr lang="en-US"/>
+              <a:rPr lang="en-US" dirty="0"/>
               <a:t>Third level</a:t>
             </a:r>
           </a:p>
           <a:p>
             <a:pPr lvl="3"/>
             <a:r>
-              <a:rPr lang="en-US"/>
+              <a:rPr lang="en-US" dirty="0"/>
               <a:t>Fourth level</a:t>
             </a:r>
           </a:p>
           <a:p>
             <a:pPr lvl="4"/>
             <a:r>
-              <a:rPr lang="en-US"/>
+              <a:rPr lang="en-US" dirty="0"/>
               <a:t>Fifth level</a:t>
             </a:r>
           </a:p>
@@ -2758,7 +4052,7 @@
           <a:p>
             <a:fld id="{B966B63C-CDDC-45F1-A941-1E23D4E81951}" type="datetimeFigureOut">
               <a:rPr lang="en-US" smtClean="0"/>
-              <a:t>8/17/2026</a:t>
+              <a:t>8/18/2026</a:t>
             </a:fld>
             <a:endParaRPr lang="en-US"/>
           </a:p>
@@ -3033,7 +4327,7 @@
           <a:p>
             <a:fld id="{B966B63C-CDDC-45F1-A941-1E23D4E81951}" type="datetimeFigureOut">
               <a:rPr lang="en-US" smtClean="0"/>
-              <a:t>8/17/2026</a:t>
+              <a:t>8/18/2026</a:t>
             </a:fld>
             <a:endParaRPr lang="en-US"/>
           </a:p>
@@ -3298,7 +4592,7 @@
           <a:p>
             <a:fld id="{B966B63C-CDDC-45F1-A941-1E23D4E81951}" type="datetimeFigureOut">
               <a:rPr lang="en-US" smtClean="0"/>
-              <a:t>8/17/2026</a:t>
+              <a:t>8/18/2026</a:t>
             </a:fld>
             <a:endParaRPr lang="en-US"/>
           </a:p>
@@ -3710,7 +5004,7 @@
           <a:p>
             <a:fld id="{B966B63C-CDDC-45F1-A941-1E23D4E81951}" type="datetimeFigureOut">
               <a:rPr lang="en-US" smtClean="0"/>
-              <a:t>8/17/2026</a:t>
+              <a:t>8/18/2026</a:t>
             </a:fld>
             <a:endParaRPr lang="en-US"/>
           </a:p>
@@ -3851,7 +5145,7 @@
           <a:p>
             <a:fld id="{B966B63C-CDDC-45F1-A941-1E23D4E81951}" type="datetimeFigureOut">
               <a:rPr lang="en-US" smtClean="0"/>
-              <a:t>8/17/2026</a:t>
+              <a:t>8/18/2026</a:t>
             </a:fld>
             <a:endParaRPr lang="en-US"/>
           </a:p>
@@ -3964,7 +5258,7 @@
           <a:p>
             <a:fld id="{B966B63C-CDDC-45F1-A941-1E23D4E81951}" type="datetimeFigureOut">
               <a:rPr lang="en-US" smtClean="0"/>
-              <a:t>8/17/2026</a:t>
+              <a:t>8/18/2026</a:t>
             </a:fld>
             <a:endParaRPr lang="en-US"/>
           </a:p>
@@ -4283,7 +5577,7 @@
           <a:p>
             <a:fld id="{B966B63C-CDDC-45F1-A941-1E23D4E81951}" type="datetimeFigureOut">
               <a:rPr lang="en-US" smtClean="0"/>
-              <a:t>8/17/2026</a:t>
+              <a:t>8/18/2026</a:t>
             </a:fld>
             <a:endParaRPr lang="en-US"/>
           </a:p>
@@ -4579,7 +5873,7 @@
           <a:p>
             <a:fld id="{B966B63C-CDDC-45F1-A941-1E23D4E81951}" type="datetimeFigureOut">
               <a:rPr lang="en-US" smtClean="0"/>
-              <a:t>8/17/2026</a:t>
+              <a:t>8/18/2026</a:t>
             </a:fld>
             <a:endParaRPr lang="en-US"/>
           </a:p>
@@ -4820,7 +6114,7 @@
           <a:p>
             <a:fld id="{B966B63C-CDDC-45F1-A941-1E23D4E81951}" type="datetimeFigureOut">
               <a:rPr lang="en-US" smtClean="0"/>
-              <a:t>8/17/2026</a:t>
+              <a:t>8/18/2026</a:t>
             </a:fld>
             <a:endParaRPr lang="en-US"/>
           </a:p>
@@ -6591,6 +7885,9 @@
           <a:bodyPr/>
           <a:lstStyle/>
           <a:p>
+            <a:pPr marL="0" indent="0">
+              <a:buNone/>
+            </a:pPr>
             <a:r>
               <a:rPr lang="en-US" dirty="0"/>
               <a:t>Za </a:t>
@@ -6645,14 +7942,6 @@
             </a:r>
             <a:r>
               <a:rPr lang="en-US" dirty="0" err="1"/>
-              <a:t>popularne</a:t>
-            </a:r>
-            <a:r>
-              <a:rPr lang="en-US" dirty="0"/>
-              <a:t> </a:t>
-            </a:r>
-            <a:r>
-              <a:rPr lang="en-US" dirty="0" err="1"/>
               <a:t>biblioteke</a:t>
             </a:r>
             <a:r>
@@ -6673,35 +7962,192 @@
             </a:r>
             <a:r>
               <a:rPr lang="en-US" dirty="0"/>
+              <a:t> </a:t>
+            </a:r>
+            <a:r>
+              <a:rPr lang="en-US" dirty="0" err="1"/>
+              <a:t>PyTorch</a:t>
+            </a:r>
+            <a:r>
+              <a:rPr lang="en-US" dirty="0"/>
+              <a:t> </a:t>
+            </a:r>
+            <a:r>
+              <a:rPr lang="en-US" dirty="0" err="1"/>
+              <a:t>i</a:t>
+            </a:r>
+            <a:r>
+              <a:rPr lang="en-US" dirty="0"/>
+              <a:t> </a:t>
+            </a:r>
+            <a:r>
+              <a:rPr lang="en-US" dirty="0" err="1"/>
+              <a:t>TorchSharp</a:t>
+            </a:r>
+            <a:r>
+              <a:rPr lang="en-US" dirty="0"/>
+              <a:t>, za Python, </a:t>
+            </a:r>
+            <a:r>
+              <a:rPr lang="en-US" dirty="0" err="1"/>
+              <a:t>odnosno</a:t>
+            </a:r>
+            <a:r>
+              <a:rPr lang="en-US" dirty="0"/>
+              <a:t> .NET </a:t>
+            </a:r>
+            <a:r>
+              <a:rPr lang="en-US" dirty="0" err="1"/>
+              <a:t>okruženje</a:t>
+            </a:r>
+            <a:r>
+              <a:rPr lang="en-US" dirty="0"/>
+              <a:t>.</a:t>
+            </a:r>
+          </a:p>
+          <a:p>
+            <a:pPr marL="0" indent="0">
+              <a:buNone/>
+            </a:pPr>
+            <a:r>
+              <a:rPr lang="en-US" dirty="0" err="1"/>
+              <a:t>Obje</a:t>
+            </a:r>
+            <a:r>
+              <a:rPr lang="en-US" dirty="0"/>
+              <a:t> </a:t>
+            </a:r>
+            <a:r>
+              <a:rPr lang="en-US" dirty="0" err="1"/>
+              <a:t>biblioteke</a:t>
+            </a:r>
+            <a:r>
+              <a:rPr lang="en-US" dirty="0"/>
+              <a:t> </a:t>
+            </a:r>
+            <a:r>
+              <a:rPr lang="en-US" dirty="0" err="1"/>
+              <a:t>su</a:t>
+            </a:r>
+            <a:r>
+              <a:rPr lang="en-US" dirty="0"/>
+              <a:t> </a:t>
+            </a:r>
+            <a:r>
+              <a:rPr lang="en-US" dirty="0" err="1"/>
+              <a:t>omotači</a:t>
+            </a:r>
+            <a:r>
+              <a:rPr lang="en-US" dirty="0"/>
+              <a:t> (</a:t>
+            </a:r>
+            <a:r>
+              <a:rPr lang="en-US" dirty="0" err="1"/>
+              <a:t>engl.</a:t>
+            </a:r>
+            <a:r>
+              <a:rPr lang="en-US" dirty="0"/>
+              <a:t> </a:t>
+            </a:r>
+            <a:r>
+              <a:rPr lang="en-US" i="1" dirty="0"/>
+              <a:t>wrappers</a:t>
+            </a:r>
+            <a:r>
+              <a:rPr lang="en-US" dirty="0"/>
+              <a:t>) </a:t>
+            </a:r>
+            <a:r>
+              <a:rPr lang="en-US" dirty="0" err="1"/>
+              <a:t>nad</a:t>
+            </a:r>
+            <a:r>
+              <a:rPr lang="en-US" dirty="0"/>
+              <a:t> </a:t>
+            </a:r>
+            <a:r>
+              <a:rPr lang="en-US" dirty="0" err="1"/>
+              <a:t>istim</a:t>
+            </a:r>
+            <a:r>
+              <a:rPr lang="en-US" dirty="0"/>
+              <a:t> C++ </a:t>
+            </a:r>
+            <a:r>
+              <a:rPr lang="en-US" dirty="0" err="1"/>
+              <a:t>jezgrom</a:t>
+            </a:r>
+            <a:r>
+              <a:rPr lang="en-US" dirty="0"/>
               <a:t>, </a:t>
             </a:r>
             <a:r>
               <a:rPr lang="en-US" dirty="0" err="1"/>
-              <a:t>PyTorch</a:t>
-            </a:r>
-            <a:r>
-              <a:rPr lang="en-US" dirty="0"/>
-              <a:t> I </a:t>
-            </a:r>
-            <a:r>
-              <a:rPr lang="en-US" dirty="0" err="1"/>
-              <a:t>TorchSharp</a:t>
-            </a:r>
-            <a:r>
-              <a:rPr lang="en-US" dirty="0"/>
-              <a:t> za Python I .NET </a:t>
-            </a:r>
-            <a:r>
-              <a:rPr lang="en-US" dirty="0" err="1"/>
-              <a:t>okruženje</a:t>
-            </a:r>
-            <a:r>
-              <a:rPr lang="en-US" dirty="0"/>
-              <a:t> </a:t>
-            </a:r>
-            <a:r>
-              <a:rPr lang="en-US" dirty="0" err="1"/>
-              <a:t>respektivno</a:t>
+              <a:t>koje</a:t>
+            </a:r>
+            <a:r>
+              <a:rPr lang="en-US" dirty="0"/>
+              <a:t> se </a:t>
+            </a:r>
+            <a:r>
+              <a:rPr lang="en-US" dirty="0" err="1"/>
+              <a:t>distribuira</a:t>
+            </a:r>
+            <a:r>
+              <a:rPr lang="en-US" dirty="0"/>
+              <a:t> </a:t>
+            </a:r>
+            <a:r>
+              <a:rPr lang="en-US" dirty="0" err="1"/>
+              <a:t>kao</a:t>
+            </a:r>
+            <a:r>
+              <a:rPr lang="en-US" dirty="0"/>
+              <a:t> </a:t>
+            </a:r>
+            <a:r>
+              <a:rPr lang="en-US" dirty="0" err="1"/>
+              <a:t>LibTorch</a:t>
+            </a:r>
+            <a:r>
+              <a:rPr lang="en-US" dirty="0"/>
+              <a:t> — u </a:t>
+            </a:r>
+            <a:r>
+              <a:rPr lang="en-US" dirty="0" err="1"/>
+              <a:t>njemu</a:t>
+            </a:r>
+            <a:r>
+              <a:rPr lang="en-US" dirty="0"/>
+              <a:t> se </a:t>
+            </a:r>
+            <a:r>
+              <a:rPr lang="en-US" dirty="0" err="1"/>
+              <a:t>izvršava</a:t>
+            </a:r>
+            <a:r>
+              <a:rPr lang="en-US" dirty="0"/>
+              <a:t> </a:t>
+            </a:r>
+            <a:r>
+              <a:rPr lang="en-US" dirty="0" err="1"/>
+              <a:t>sva</a:t>
+            </a:r>
+            <a:r>
+              <a:rPr lang="en-US" dirty="0"/>
+              <a:t> </a:t>
+            </a:r>
+            <a:r>
+              <a:rPr lang="en-US" dirty="0" err="1"/>
+              <a:t>logika</a:t>
+            </a:r>
+            <a:r>
+              <a:rPr lang="en-US" dirty="0"/>
+              <a:t> </a:t>
+            </a:r>
+            <a:r>
+              <a:rPr lang="en-US" dirty="0" err="1"/>
+              <a:t>treniranja</a:t>
             </a:r>
             <a:r>
               <a:rPr lang="en-US" dirty="0"/>
@@ -6709,97 +8155,12 @@
             </a:r>
           </a:p>
           <a:p>
-            <a:r>
-              <a:rPr lang="en-US" dirty="0" err="1"/>
-              <a:t>Obje</a:t>
-            </a:r>
-            <a:r>
-              <a:rPr lang="en-US" dirty="0"/>
-              <a:t> </a:t>
-            </a:r>
-            <a:r>
-              <a:rPr lang="en-US" dirty="0" err="1"/>
-              <a:t>navedene</a:t>
-            </a:r>
-            <a:r>
-              <a:rPr lang="en-US" dirty="0"/>
-              <a:t> </a:t>
-            </a:r>
-            <a:r>
-              <a:rPr lang="en-US" dirty="0" err="1"/>
-              <a:t>biblioteke</a:t>
-            </a:r>
-            <a:r>
-              <a:rPr lang="en-US" dirty="0"/>
-              <a:t> </a:t>
-            </a:r>
-            <a:r>
-              <a:rPr lang="en-US" dirty="0" err="1"/>
-              <a:t>su</a:t>
-            </a:r>
-            <a:r>
-              <a:rPr lang="en-US" dirty="0"/>
-              <a:t> </a:t>
-            </a:r>
-            <a:r>
-              <a:rPr lang="en-US" dirty="0" err="1"/>
-              <a:t>takozvani</a:t>
-            </a:r>
-            <a:r>
-              <a:rPr lang="en-US" dirty="0"/>
-              <a:t> </a:t>
-            </a:r>
-            <a:r>
-              <a:rPr lang="en-US" dirty="0" err="1"/>
-              <a:t>wrapperi</a:t>
-            </a:r>
-            <a:r>
-              <a:rPr lang="en-US" dirty="0"/>
-              <a:t> koji </a:t>
-            </a:r>
-            <a:r>
-              <a:rPr lang="en-US" dirty="0" err="1"/>
-              <a:t>pozivaju</a:t>
-            </a:r>
-            <a:r>
-              <a:rPr lang="en-US" dirty="0"/>
-              <a:t> </a:t>
-            </a:r>
-            <a:r>
-              <a:rPr lang="en-US" dirty="0" err="1"/>
-              <a:t>internu</a:t>
-            </a:r>
-            <a:r>
-              <a:rPr lang="en-US" dirty="0"/>
-              <a:t> </a:t>
-            </a:r>
-            <a:r>
-              <a:rPr lang="en-US" dirty="0" err="1"/>
-              <a:t>logiku</a:t>
-            </a:r>
-            <a:r>
-              <a:rPr lang="en-US" dirty="0"/>
-              <a:t> </a:t>
-            </a:r>
-            <a:r>
-              <a:rPr lang="en-US" dirty="0" err="1"/>
-              <a:t>biblioteke</a:t>
-            </a:r>
-            <a:r>
-              <a:rPr lang="en-US" dirty="0"/>
-              <a:t> </a:t>
-            </a:r>
-            <a:r>
-              <a:rPr lang="en-US" dirty="0" err="1"/>
-              <a:t>LibTorch</a:t>
-            </a:r>
-            <a:r>
-              <a:rPr lang="en-US" dirty="0"/>
-              <a:t>. </a:t>
-            </a:r>
-            <a:r>
-              <a:rPr lang="en-US" dirty="0" err="1"/>
-              <a:t>LibTorch</a:t>
+            <a:pPr marL="0" indent="0">
+              <a:buNone/>
+            </a:pPr>
+            <a:r>
+              <a:rPr lang="en-US" dirty="0" err="1"/>
+              <a:t>Kako</a:t>
             </a:r>
             <a:r>
               <a:rPr lang="en-US" dirty="0"/>
@@ -6807,23 +8168,7 @@
             </a:r>
             <a:r>
               <a:rPr lang="en-US" dirty="0" err="1"/>
-              <a:t>napisana</a:t>
-            </a:r>
-            <a:r>
-              <a:rPr lang="en-US" dirty="0"/>
-              <a:t> u C++ u </a:t>
-            </a:r>
-            <a:r>
-              <a:rPr lang="en-US" dirty="0" err="1"/>
-              <a:t>kojoj</a:t>
-            </a:r>
-            <a:r>
-              <a:rPr lang="en-US" dirty="0"/>
-              <a:t> se </a:t>
-            </a:r>
-            <a:r>
-              <a:rPr lang="en-US" dirty="0" err="1"/>
-              <a:t>izvršava</a:t>
+              <a:t>pozadinska</a:t>
             </a:r>
             <a:r>
               <a:rPr lang="en-US" dirty="0"/>
@@ -6839,169 +8184,84 @@
             </a:r>
             <a:r>
               <a:rPr lang="en-US" dirty="0" err="1"/>
-              <a:t>prilikom</a:t>
-            </a:r>
-            <a:r>
-              <a:rPr lang="en-US" dirty="0"/>
-              <a:t> </a:t>
-            </a:r>
-            <a:r>
-              <a:rPr lang="en-US" dirty="0" err="1"/>
-              <a:t>treniranja</a:t>
+              <a:t>ista</a:t>
+            </a:r>
+            <a:r>
+              <a:rPr lang="en-US" dirty="0"/>
+              <a:t>, </a:t>
+            </a:r>
+            <a:r>
+              <a:rPr lang="en-US" dirty="0" err="1"/>
+              <a:t>odabir</a:t>
+            </a:r>
+            <a:r>
+              <a:rPr lang="en-US" dirty="0"/>
+              <a:t> Python </a:t>
+            </a:r>
+            <a:r>
+              <a:rPr lang="en-US" dirty="0" err="1"/>
+              <a:t>ili</a:t>
+            </a:r>
+            <a:r>
+              <a:rPr lang="en-US" dirty="0"/>
+              <a:t> .NET </a:t>
+            </a:r>
+            <a:r>
+              <a:rPr lang="en-US" dirty="0" err="1"/>
+              <a:t>okruženja</a:t>
+            </a:r>
+            <a:r>
+              <a:rPr lang="en-US" dirty="0"/>
+              <a:t> </a:t>
+            </a:r>
+            <a:r>
+              <a:rPr lang="en-US" dirty="0" err="1"/>
+              <a:t>teorijski</a:t>
+            </a:r>
+            <a:r>
+              <a:rPr lang="en-US" dirty="0"/>
+              <a:t> ne bi </a:t>
+            </a:r>
+            <a:r>
+              <a:rPr lang="en-US" dirty="0" err="1"/>
+              <a:t>trebao</a:t>
+            </a:r>
+            <a:r>
+              <a:rPr lang="en-US" dirty="0"/>
+              <a:t> </a:t>
+            </a:r>
+            <a:r>
+              <a:rPr lang="en-US" dirty="0" err="1"/>
+              <a:t>značajno</a:t>
+            </a:r>
+            <a:r>
+              <a:rPr lang="en-US" dirty="0"/>
+              <a:t> </a:t>
+            </a:r>
+            <a:r>
+              <a:rPr lang="en-US" dirty="0" err="1"/>
+              <a:t>utjecati</a:t>
+            </a:r>
+            <a:r>
+              <a:rPr lang="en-US" dirty="0"/>
+              <a:t> </a:t>
+            </a:r>
+            <a:r>
+              <a:rPr lang="en-US" dirty="0" err="1"/>
+              <a:t>na</a:t>
+            </a:r>
+            <a:r>
+              <a:rPr lang="en-US" dirty="0"/>
+              <a:t> </a:t>
+            </a:r>
+            <a:r>
+              <a:rPr lang="en-US" dirty="0" err="1"/>
+              <a:t>rezultate</a:t>
             </a:r>
             <a:r>
               <a:rPr lang="en-US" dirty="0"/>
               <a:t>.</a:t>
             </a:r>
-          </a:p>
-          <a:p>
-            <a:r>
-              <a:rPr lang="en-US" dirty="0" err="1"/>
-              <a:t>Kako</a:t>
-            </a:r>
-            <a:r>
-              <a:rPr lang="en-US" dirty="0"/>
-              <a:t> </a:t>
-            </a:r>
-            <a:r>
-              <a:rPr lang="en-US" dirty="0" err="1"/>
-              <a:t>obje</a:t>
-            </a:r>
-            <a:r>
-              <a:rPr lang="en-US" dirty="0"/>
-              <a:t> date </a:t>
-            </a:r>
-            <a:r>
-              <a:rPr lang="en-US" dirty="0" err="1"/>
-              <a:t>biblioteke</a:t>
-            </a:r>
-            <a:r>
-              <a:rPr lang="en-US" dirty="0"/>
-              <a:t> </a:t>
-            </a:r>
-            <a:r>
-              <a:rPr lang="en-US" dirty="0" err="1"/>
-              <a:t>koriste</a:t>
-            </a:r>
-            <a:r>
-              <a:rPr lang="en-US" dirty="0"/>
-              <a:t> </a:t>
-            </a:r>
-            <a:r>
-              <a:rPr lang="en-US" dirty="0" err="1"/>
-              <a:t>istu</a:t>
-            </a:r>
-            <a:r>
-              <a:rPr lang="en-US" dirty="0"/>
-              <a:t> </a:t>
-            </a:r>
-            <a:r>
-              <a:rPr lang="en-US" dirty="0" err="1"/>
-              <a:t>pozadinsku</a:t>
-            </a:r>
-            <a:r>
-              <a:rPr lang="en-US" dirty="0"/>
-              <a:t> </a:t>
-            </a:r>
-            <a:r>
-              <a:rPr lang="en-US" dirty="0" err="1"/>
-              <a:t>logiku</a:t>
-            </a:r>
-            <a:r>
-              <a:rPr lang="en-US" dirty="0"/>
-              <a:t>, </a:t>
-            </a:r>
-            <a:r>
-              <a:rPr lang="en-US" dirty="0" err="1"/>
-              <a:t>odabir</a:t>
-            </a:r>
-            <a:r>
-              <a:rPr lang="en-US" dirty="0"/>
-              <a:t> Python </a:t>
-            </a:r>
-            <a:r>
-              <a:rPr lang="en-US" dirty="0" err="1"/>
-              <a:t>ili</a:t>
-            </a:r>
-            <a:r>
-              <a:rPr lang="en-US" dirty="0"/>
-              <a:t> .NET </a:t>
-            </a:r>
-            <a:r>
-              <a:rPr lang="en-US" dirty="0" err="1"/>
-              <a:t>ekosistema</a:t>
-            </a:r>
-            <a:r>
-              <a:rPr lang="en-US" dirty="0"/>
-              <a:t> za </a:t>
-            </a:r>
-            <a:r>
-              <a:rPr lang="en-US" dirty="0" err="1"/>
-              <a:t>rješavanja</a:t>
-            </a:r>
-            <a:r>
-              <a:rPr lang="en-US" dirty="0"/>
-              <a:t> </a:t>
-            </a:r>
-            <a:r>
-              <a:rPr lang="en-US" dirty="0" err="1"/>
-              <a:t>datog</a:t>
-            </a:r>
-            <a:r>
-              <a:rPr lang="en-US" dirty="0"/>
-              <a:t> </a:t>
-            </a:r>
-            <a:r>
-              <a:rPr lang="en-US" dirty="0" err="1"/>
-              <a:t>problema</a:t>
-            </a:r>
-            <a:r>
-              <a:rPr lang="en-US" dirty="0"/>
-              <a:t> bi </a:t>
-            </a:r>
-            <a:r>
-              <a:rPr lang="en-US" dirty="0" err="1"/>
-              <a:t>teoretski</a:t>
-            </a:r>
-            <a:r>
-              <a:rPr lang="en-US" dirty="0"/>
-              <a:t> </a:t>
-            </a:r>
-            <a:r>
-              <a:rPr lang="en-US" dirty="0" err="1"/>
-              <a:t>trebalo</a:t>
-            </a:r>
-            <a:r>
-              <a:rPr lang="en-US" dirty="0"/>
-              <a:t> </a:t>
-            </a:r>
-            <a:r>
-              <a:rPr lang="en-US" dirty="0" err="1"/>
-              <a:t>biti</a:t>
-            </a:r>
-            <a:r>
-              <a:rPr lang="en-US" dirty="0"/>
-              <a:t> </a:t>
-            </a:r>
-            <a:r>
-              <a:rPr lang="en-US" dirty="0" err="1"/>
-              <a:t>veoma</a:t>
-            </a:r>
-            <a:r>
-              <a:rPr lang="en-US" dirty="0"/>
-              <a:t> </a:t>
-            </a:r>
-            <a:r>
-              <a:rPr lang="en-US" dirty="0" err="1"/>
-              <a:t>slično</a:t>
-            </a:r>
-            <a:r>
-              <a:rPr lang="en-US" dirty="0"/>
-              <a:t>.</a:t>
-            </a:r>
-          </a:p>
-          <a:p>
-            <a:endParaRPr lang="en-US" dirty="0"/>
           </a:p>
         </p:txBody>
       </p:sp>
@@ -7058,15 +8318,7 @@
           <a:p>
             <a:r>
               <a:rPr lang="en-US" dirty="0" err="1"/>
-              <a:t>Trening</a:t>
-            </a:r>
-            <a:r>
-              <a:rPr lang="en-US" dirty="0"/>
-              <a:t> </a:t>
-            </a:r>
-            <a:r>
-              <a:rPr lang="en-US" dirty="0" err="1"/>
-              <a:t>podaci</a:t>
+              <a:t>Podaci</a:t>
             </a:r>
             <a:endParaRPr lang="en-US" dirty="0"/>
           </a:p>
@@ -7097,44 +8349,8 @@
               <a:buNone/>
             </a:pPr>
             <a:r>
-              <a:rPr lang="en-US" dirty="0"/>
-              <a:t>Za </a:t>
-            </a:r>
-            <a:r>
-              <a:rPr lang="en-US" dirty="0" err="1"/>
-              <a:t>treniranje</a:t>
-            </a:r>
-            <a:r>
-              <a:rPr lang="en-US" dirty="0"/>
-              <a:t> </a:t>
-            </a:r>
-            <a:r>
-              <a:rPr lang="en-US" dirty="0" err="1"/>
-              <a:t>konvolucione</a:t>
-            </a:r>
-            <a:r>
-              <a:rPr lang="en-US" dirty="0"/>
-              <a:t> </a:t>
-            </a:r>
-            <a:r>
-              <a:rPr lang="en-US" dirty="0" err="1"/>
-              <a:t>neuronske</a:t>
-            </a:r>
-            <a:r>
-              <a:rPr lang="en-US" dirty="0"/>
-              <a:t> </a:t>
-            </a:r>
-            <a:r>
-              <a:rPr lang="en-US" dirty="0" err="1"/>
-              <a:t>mreže</a:t>
-            </a:r>
-            <a:r>
-              <a:rPr lang="en-US" dirty="0"/>
-              <a:t> </a:t>
-            </a:r>
-            <a:r>
-              <a:rPr lang="en-US" dirty="0" err="1"/>
-              <a:t>korišten</a:t>
+              <a:rPr lang="en-US" dirty="0" err="1"/>
+              <a:t>Korišten</a:t>
             </a:r>
             <a:r>
               <a:rPr lang="en-US" dirty="0"/>
@@ -7142,6 +8358,22 @@
             </a:r>
             <a:r>
               <a:rPr lang="en-US" dirty="0" err="1"/>
+              <a:t>javno</a:t>
+            </a:r>
+            <a:r>
+              <a:rPr lang="en-US" dirty="0"/>
+              <a:t> </a:t>
+            </a:r>
+            <a:r>
+              <a:rPr lang="en-US" dirty="0" err="1"/>
+              <a:t>dostupan</a:t>
+            </a:r>
+            <a:r>
+              <a:rPr lang="en-US" dirty="0"/>
+              <a:t> </a:t>
+            </a:r>
+            <a:r>
+              <a:rPr lang="en-US" dirty="0" err="1"/>
               <a:t>skup</a:t>
             </a:r>
             <a:r>
@@ -7154,6 +8386,30 @@
             </a:r>
             <a:r>
               <a:rPr lang="en-US" dirty="0"/>
+              <a:t> IQ-OTH/NCCD (</a:t>
+            </a:r>
+            <a:r>
+              <a:rPr lang="en-US" dirty="0" err="1"/>
+              <a:t>engl.</a:t>
+            </a:r>
+            <a:r>
+              <a:rPr lang="en-US" dirty="0"/>
+              <a:t> </a:t>
+            </a:r>
+            <a:r>
+              <a:rPr lang="en-US" i="1" dirty="0"/>
+              <a:t>Iraq-Oncology Teaching Hospital / National Center for Cancer Diseases</a:t>
+            </a:r>
+            <a:r>
+              <a:rPr lang="en-US" dirty="0"/>
+              <a:t>), </a:t>
+            </a:r>
+            <a:r>
+              <a:rPr lang="en-US" dirty="0" err="1"/>
+              <a:t>preuzet</a:t>
+            </a:r>
+            <a:r>
+              <a:rPr lang="en-US" dirty="0"/>
               <a:t> </a:t>
             </a:r>
             <a:r>
@@ -7162,56 +8418,13 @@
             </a:r>
             <a:r>
               <a:rPr lang="en-US" dirty="0"/>
-              <a:t> </a:t>
-            </a:r>
-            <a:r>
-              <a:rPr lang="en-US" dirty="0" err="1"/>
-              <a:t>stranica</a:t>
-            </a:r>
-            <a:r>
-              <a:rPr lang="en-US" dirty="0"/>
-              <a:t> Kaggle IQ-OTH/NCCD(</a:t>
-            </a:r>
-            <a:r>
-              <a:rPr lang="en-US" dirty="0" err="1"/>
-              <a:t>eng.</a:t>
-            </a:r>
-            <a:r>
-              <a:rPr lang="en-US" dirty="0"/>
-              <a:t> </a:t>
-            </a:r>
-            <a:r>
-              <a:rPr lang="hr-HR" i="1" dirty="0">
-                <a:effectLst/>
-                <a:latin typeface="Times New Roman" panose="02020603050405020304" pitchFamily="18" charset="0"/>
-                <a:ea typeface="Calibri" panose="020F0502020204030204" pitchFamily="34" charset="0"/>
-              </a:rPr>
-              <a:t>Iraq-Oncology Teaching Hospital</a:t>
-            </a:r>
-            <a:r>
-              <a:rPr lang="en-GB" i="1" dirty="0">
-                <a:effectLst/>
-                <a:latin typeface="Times New Roman" panose="02020603050405020304" pitchFamily="18" charset="0"/>
-                <a:ea typeface="Calibri" panose="020F0502020204030204" pitchFamily="34" charset="0"/>
-              </a:rPr>
-              <a:t>/National </a:t>
-            </a:r>
-            <a:r>
-              <a:rPr lang="en-GB" i="1" dirty="0" err="1">
-                <a:effectLst/>
-                <a:latin typeface="Times New Roman" panose="02020603050405020304" pitchFamily="18" charset="0"/>
-                <a:ea typeface="Calibri" panose="020F0502020204030204" pitchFamily="34" charset="0"/>
-              </a:rPr>
-              <a:t>Center</a:t>
-            </a:r>
-            <a:r>
-              <a:rPr lang="en-GB" i="1" dirty="0">
-                <a:effectLst/>
-                <a:latin typeface="Times New Roman" panose="02020603050405020304" pitchFamily="18" charset="0"/>
-                <a:ea typeface="Calibri" panose="020F0502020204030204" pitchFamily="34" charset="0"/>
-              </a:rPr>
-              <a:t> for Cancer Diseases).</a:t>
-            </a:r>
+              <a:t> Kaggle </a:t>
+            </a:r>
+            <a:r>
+              <a:rPr lang="en-US" dirty="0" err="1"/>
+              <a:t>platforme</a:t>
+            </a:r>
+            <a:endParaRPr lang="en-US" dirty="0"/>
           </a:p>
           <a:p>
             <a:pPr marL="0" indent="0">
@@ -7227,14 +8440,6 @@
             </a:r>
             <a:r>
               <a:rPr lang="en-US" dirty="0" err="1"/>
-              <a:t>podataka</a:t>
-            </a:r>
-            <a:r>
-              <a:rPr lang="en-US" dirty="0"/>
-              <a:t> </a:t>
-            </a:r>
-            <a:r>
-              <a:rPr lang="en-US" dirty="0" err="1"/>
               <a:t>sadrži</a:t>
             </a:r>
             <a:r>
@@ -7271,7 +8476,7 @@
             </a:r>
             <a:r>
               <a:rPr lang="en-US" dirty="0"/>
-              <a:t> 1190 </a:t>
+              <a:t> 1097 </a:t>
             </a:r>
             <a:r>
               <a:rPr lang="en-US" dirty="0" err="1"/>
@@ -7283,27 +8488,11 @@
             </a:r>
             <a:r>
               <a:rPr lang="en-US" dirty="0" err="1"/>
-              <a:t>koje</a:t>
-            </a:r>
-            <a:r>
-              <a:rPr lang="en-US" dirty="0"/>
-              <a:t> </a:t>
-            </a:r>
-            <a:r>
-              <a:rPr lang="en-US" dirty="0" err="1"/>
-              <a:t>su</a:t>
-            </a:r>
-            <a:r>
-              <a:rPr lang="en-US" dirty="0"/>
-              <a:t> </a:t>
-            </a:r>
-            <a:r>
-              <a:rPr lang="en-US" dirty="0" err="1"/>
-              <a:t>grupisane</a:t>
-            </a:r>
-            <a:r>
-              <a:rPr lang="en-US" dirty="0"/>
-              <a:t> u 3 </a:t>
+              <a:t>grupisanih</a:t>
+            </a:r>
+            <a:r>
+              <a:rPr lang="en-US" dirty="0"/>
+              <a:t> u tri </a:t>
             </a:r>
             <a:r>
               <a:rPr lang="en-US" dirty="0" err="1"/>
@@ -7311,14 +8500,10 @@
             </a:r>
             <a:r>
               <a:rPr lang="en-US" dirty="0"/>
-              <a:t>:</a:t>
-            </a:r>
-          </a:p>
-          <a:p>
-            <a:pPr>
-              <a:buFontTx/>
-              <a:buChar char="-"/>
-            </a:pPr>
+              <a:t>: </a:t>
+            </a:r>
+          </a:p>
+          <a:p>
             <a:r>
               <a:rPr lang="en-US" dirty="0" err="1"/>
               <a:t>Maligno</a:t>
@@ -7334,10 +8519,6 @@
             <a:endParaRPr lang="en-US" dirty="0"/>
           </a:p>
           <a:p>
-            <a:pPr>
-              <a:buFontTx/>
-              <a:buChar char="-"/>
-            </a:pPr>
             <a:r>
               <a:rPr lang="en-US" dirty="0" err="1"/>
               <a:t>Benigno</a:t>
@@ -7353,10 +8534,6 @@
             <a:endParaRPr lang="en-US" dirty="0"/>
           </a:p>
           <a:p>
-            <a:pPr>
-              <a:buFontTx/>
-              <a:buChar char="-"/>
-            </a:pPr>
             <a:r>
               <a:rPr lang="en-US" dirty="0" err="1"/>
               <a:t>Normalno</a:t>
@@ -7387,6 +8564,93 @@
 </file>
 
 <file path=ppt/slides/slide6.xml><?xml version="1.0" encoding="utf-8"?>
+<p:sld xmlns:a="http://schemas.openxmlformats.org/drawingml/2006/main" xmlns:r="http://schemas.openxmlformats.org/officeDocument/2006/relationships" xmlns:p="http://schemas.openxmlformats.org/presentationml/2006/main">
+  <p:cSld>
+    <p:spTree>
+      <p:nvGrpSpPr>
+        <p:cNvPr id="1" name=""/>
+        <p:cNvGrpSpPr/>
+        <p:nvPr/>
+      </p:nvGrpSpPr>
+      <p:grpSpPr>
+        <a:xfrm>
+          <a:off x="0" y="0"/>
+          <a:ext cx="0" cy="0"/>
+          <a:chOff x="0" y="0"/>
+          <a:chExt cx="0" cy="0"/>
+        </a:xfrm>
+      </p:grpSpPr>
+      <p:sp>
+        <p:nvSpPr>
+          <p:cNvPr id="2" name="Title 1">
+            <a:extLst>
+              <a:ext uri="{FF2B5EF4-FFF2-40B4-BE49-F238E27FC236}">
+                <a16:creationId xmlns:a16="http://schemas.microsoft.com/office/drawing/2014/main" id="{093D66E3-E65B-4C1C-A898-C193B8AD7D2D}"/>
+              </a:ext>
+            </a:extLst>
+          </p:cNvPr>
+          <p:cNvSpPr>
+            <a:spLocks noGrp="1"/>
+          </p:cNvSpPr>
+          <p:nvPr>
+            <p:ph type="title"/>
+          </p:nvPr>
+        </p:nvSpPr>
+        <p:spPr/>
+        <p:txBody>
+          <a:bodyPr/>
+          <a:lstStyle/>
+          <a:p>
+            <a:r>
+              <a:rPr lang="en-US" dirty="0" err="1"/>
+              <a:t>Podjela</a:t>
+            </a:r>
+            <a:r>
+              <a:rPr lang="en-US" dirty="0"/>
+              <a:t> </a:t>
+            </a:r>
+          </a:p>
+        </p:txBody>
+      </p:sp>
+      <p:sp>
+        <p:nvSpPr>
+          <p:cNvPr id="3" name="Content Placeholder 2">
+            <a:extLst>
+              <a:ext uri="{FF2B5EF4-FFF2-40B4-BE49-F238E27FC236}">
+                <a16:creationId xmlns:a16="http://schemas.microsoft.com/office/drawing/2014/main" id="{DAE8AA96-E28E-4CAE-8775-04F1D24AA98A}"/>
+              </a:ext>
+            </a:extLst>
+          </p:cNvPr>
+          <p:cNvSpPr>
+            <a:spLocks noGrp="1"/>
+          </p:cNvSpPr>
+          <p:nvPr>
+            <p:ph idx="1"/>
+          </p:nvPr>
+        </p:nvSpPr>
+        <p:spPr/>
+        <p:txBody>
+          <a:bodyPr/>
+          <a:lstStyle/>
+          <a:p>
+            <a:endParaRPr lang="en-US"/>
+          </a:p>
+        </p:txBody>
+      </p:sp>
+    </p:spTree>
+    <p:extLst>
+      <p:ext uri="{BB962C8B-B14F-4D97-AF65-F5344CB8AC3E}">
+        <p14:creationId xmlns:p14="http://schemas.microsoft.com/office/powerpoint/2010/main" val="3503353261"/>
+      </p:ext>
+    </p:extLst>
+  </p:cSld>
+  <p:clrMapOvr>
+    <a:masterClrMapping/>
+  </p:clrMapOvr>
+</p:sld>
+</file>
+
+<file path=ppt/slides/slide7.xml><?xml version="1.0" encoding="utf-8"?>
 <p:sld xmlns:a="http://schemas.openxmlformats.org/drawingml/2006/main" xmlns:r="http://schemas.openxmlformats.org/officeDocument/2006/relationships" xmlns:p="http://schemas.openxmlformats.org/presentationml/2006/main">
   <p:cSld>
     <p:spTree>

</xml_diff>